<commit_message>
Update slides: add hypothesis testing step to process slide
</commit_message>
<xml_diff>
--- a/slides/capstone_presentation.pptx
+++ b/slides/capstone_presentation.pptx
@@ -4,15 +4,15 @@
   <p:sldMasterIdLst>
     <p:sldMasterId id="2147483648" r:id="rId1"/>
   </p:sldMasterIdLst>
-  <p:notesMasterIdLst>
-    <p:notesMasterId r:id="rId5"/>
-  </p:notesMasterIdLst>
   <p:sldIdLst>
     <p:sldId id="256" r:id="rId2"/>
     <p:sldId id="257" r:id="rId3"/>
     <p:sldId id="258" r:id="rId4"/>
   </p:sldIdLst>
-  <p:sldSz cx="9144000" cy="5143500" type="screen16x9"/>
+  <p:notesMasterIdLst>
+    <p:notesMasterId r:id="rId5"/>
+  </p:notesMasterIdLst>
+  <p:sldSz cx="9144000" cy="5143500"/>
   <p:notesSz cx="5143500" cy="9144000"/>
   <p:defaultTextStyle>
     <a:lvl1pPr marL="0" algn="l" defTabSz="914400" rtl="0" eaLnBrk="1" latinLnBrk="0" hangingPunct="1">
@@ -106,11 +106,6 @@
       </a:defRPr>
     </a:lvl9pPr>
   </p:defaultTextStyle>
-  <p:extLst>
-    <p:ext uri="{EFAFB233-063F-42B5-8137-9DF3F51BA10A}">
-      <p15:sldGuideLst xmlns:p15="http://schemas.microsoft.com/office/powerpoint/2012/main"/>
-    </p:ext>
-  </p:extLst>
 </p:presentation>
 </file>
 
@@ -136,10 +131,234 @@
           <a:chExt cx="0" cy="0"/>
         </a:xfrm>
       </p:grpSpPr>
+      <p:sp>
+        <p:nvSpPr>
+          <p:cNvPr id="2" name="Header Placeholder 1"/>
+          <p:cNvSpPr>
+            <a:spLocks noGrp="1"/>
+          </p:cNvSpPr>
+          <p:nvPr>
+            <p:ph type="hdr" sz="quarter"/>
+          </p:nvPr>
+        </p:nvSpPr>
+        <p:spPr>
+          <a:xfrm>
+            <a:off x="0" y="0"/>
+            <a:ext cx="2971800" cy="458788"/>
+          </a:xfrm>
+          <a:prstGeom prst="rect">
+            <a:avLst/>
+          </a:prstGeom>
+        </p:spPr>
+        <p:txBody>
+          <a:bodyPr vert="horz" lIns="91440" tIns="45720" rIns="91440" bIns="45720" rtlCol="0"/>
+          <a:lstStyle>
+            <a:lvl1pPr algn="l">
+              <a:defRPr sz="1200"/>
+            </a:lvl1pPr>
+          </a:lstStyle>
+          <a:p>
+            <a:endParaRPr lang="en-US"/>
+          </a:p>
+        </p:txBody>
+      </p:sp>
+      <p:sp>
+        <p:nvSpPr>
+          <p:cNvPr id="3" name="Date Placeholder 2"/>
+          <p:cNvSpPr>
+            <a:spLocks noGrp="1"/>
+          </p:cNvSpPr>
+          <p:nvPr>
+            <p:ph type="dt" idx="1"/>
+          </p:nvPr>
+        </p:nvSpPr>
+        <p:spPr>
+          <a:xfrm>
+            <a:off x="3884613" y="0"/>
+            <a:ext cx="2971800" cy="458788"/>
+          </a:xfrm>
+          <a:prstGeom prst="rect">
+            <a:avLst/>
+          </a:prstGeom>
+        </p:spPr>
+        <p:txBody>
+          <a:bodyPr vert="horz" lIns="91440" tIns="45720" rIns="91440" bIns="45720" rtlCol="0"/>
+          <a:lstStyle>
+            <a:lvl1pPr algn="r">
+              <a:defRPr sz="1200"/>
+            </a:lvl1pPr>
+          </a:lstStyle>
+          <a:p>
+            <a:fld id="{5282F153-3F37-0F45-9E97-73ACFA13230C}" type="datetimeFigureOut">
+              <a:rPr lang="en-US"/>
+              <a:t>7/23/19</a:t>
+            </a:fld>
+            <a:endParaRPr lang="en-US"/>
+          </a:p>
+        </p:txBody>
+      </p:sp>
+      <p:sp>
+        <p:nvSpPr>
+          <p:cNvPr id="4" name="Slide Image Placeholder 3"/>
+          <p:cNvSpPr>
+            <a:spLocks noGrp="1" noRot="1" noChangeAspect="1"/>
+          </p:cNvSpPr>
+          <p:nvPr>
+            <p:ph type="sldImg" idx="2"/>
+          </p:nvPr>
+        </p:nvSpPr>
+        <p:spPr>
+          <a:xfrm>
+            <a:off x="685800" y="1143000"/>
+            <a:ext cx="5486400" cy="3086100"/>
+          </a:xfrm>
+          <a:prstGeom prst="rect">
+            <a:avLst/>
+          </a:prstGeom>
+          <a:noFill/>
+          <a:ln w="12700">
+            <a:solidFill>
+              <a:prstClr val="black"/>
+            </a:solidFill>
+          </a:ln>
+        </p:spPr>
+        <p:txBody>
+          <a:bodyPr vert="horz" lIns="91440" tIns="45720" rIns="91440" bIns="45720" rtlCol="0" anchor="ctr"/>
+          <a:lstStyle/>
+          <a:p>
+            <a:endParaRPr lang="en-US"/>
+          </a:p>
+        </p:txBody>
+      </p:sp>
+      <p:sp>
+        <p:nvSpPr>
+          <p:cNvPr id="5" name="Notes Placeholder 4"/>
+          <p:cNvSpPr>
+            <a:spLocks noGrp="1"/>
+          </p:cNvSpPr>
+          <p:nvPr>
+            <p:ph type="body" sz="quarter" idx="3"/>
+          </p:nvPr>
+        </p:nvSpPr>
+        <p:spPr>
+          <a:xfrm>
+            <a:off x="685800" y="4400550"/>
+            <a:ext cx="5486400" cy="3600450"/>
+          </a:xfrm>
+          <a:prstGeom prst="rect">
+            <a:avLst/>
+          </a:prstGeom>
+        </p:spPr>
+        <p:txBody>
+          <a:bodyPr vert="horz" lIns="91440" tIns="45720" rIns="91440" bIns="45720" rtlCol="0"/>
+          <a:lstStyle/>
+          <a:p>
+            <a:pPr lvl="0"/>
+            <a:r>
+              <a:rPr lang="en-US"/>
+              <a:t>Click to edit Master text styles</a:t>
+            </a:r>
+          </a:p>
+          <a:p>
+            <a:pPr lvl="1"/>
+            <a:r>
+              <a:rPr lang="en-US"/>
+              <a:t>Second level</a:t>
+            </a:r>
+          </a:p>
+          <a:p>
+            <a:pPr lvl="2"/>
+            <a:r>
+              <a:rPr lang="en-US"/>
+              <a:t>Third level</a:t>
+            </a:r>
+          </a:p>
+          <a:p>
+            <a:pPr lvl="3"/>
+            <a:r>
+              <a:rPr lang="en-US"/>
+              <a:t>Fourth level</a:t>
+            </a:r>
+          </a:p>
+          <a:p>
+            <a:pPr lvl="4"/>
+            <a:r>
+              <a:rPr lang="en-US"/>
+              <a:t>Fifth level</a:t>
+            </a:r>
+          </a:p>
+        </p:txBody>
+      </p:sp>
+      <p:sp>
+        <p:nvSpPr>
+          <p:cNvPr id="6" name="Footer Placeholder 5"/>
+          <p:cNvSpPr>
+            <a:spLocks noGrp="1"/>
+          </p:cNvSpPr>
+          <p:nvPr>
+            <p:ph type="ftr" sz="quarter" idx="4"/>
+          </p:nvPr>
+        </p:nvSpPr>
+        <p:spPr>
+          <a:xfrm>
+            <a:off x="0" y="8685213"/>
+            <a:ext cx="2971800" cy="458787"/>
+          </a:xfrm>
+          <a:prstGeom prst="rect">
+            <a:avLst/>
+          </a:prstGeom>
+        </p:spPr>
+        <p:txBody>
+          <a:bodyPr vert="horz" lIns="91440" tIns="45720" rIns="91440" bIns="45720" rtlCol="0" anchor="b"/>
+          <a:lstStyle>
+            <a:lvl1pPr algn="l">
+              <a:defRPr sz="1200"/>
+            </a:lvl1pPr>
+          </a:lstStyle>
+          <a:p>
+            <a:endParaRPr lang="en-US"/>
+          </a:p>
+        </p:txBody>
+      </p:sp>
+      <p:sp>
+        <p:nvSpPr>
+          <p:cNvPr id="7" name="Slide Number Placeholder 6"/>
+          <p:cNvSpPr>
+            <a:spLocks noGrp="1"/>
+          </p:cNvSpPr>
+          <p:nvPr>
+            <p:ph type="sldNum" sz="quarter" idx="5"/>
+          </p:nvPr>
+        </p:nvSpPr>
+        <p:spPr>
+          <a:xfrm>
+            <a:off x="3884613" y="8685213"/>
+            <a:ext cx="2971800" cy="458787"/>
+          </a:xfrm>
+          <a:prstGeom prst="rect">
+            <a:avLst/>
+          </a:prstGeom>
+        </p:spPr>
+        <p:txBody>
+          <a:bodyPr vert="horz" lIns="91440" tIns="45720" rIns="91440" bIns="45720" rtlCol="0" anchor="b"/>
+          <a:lstStyle>
+            <a:lvl1pPr algn="r">
+              <a:defRPr sz="1200"/>
+            </a:lvl1pPr>
+          </a:lstStyle>
+          <a:p>
+            <a:fld id="{CE5E9CC1-C706-0F49-92D6-E571CC5EEA8F}" type="slidenum">
+              <a:rPr lang="en-US"/>
+              <a:t>‹#›</a:t>
+            </a:fld>
+            <a:endParaRPr lang="en-US"/>
+          </a:p>
+        </p:txBody>
+      </p:sp>
     </p:spTree>
     <p:extLst>
       <p:ext uri="{BB962C8B-B14F-4D97-AF65-F5344CB8AC3E}">
-        <p14:creationId xmlns:p14="http://schemas.microsoft.com/office/powerpoint/2010/main" val="1052483295"/>
+        <p14:creationId xmlns:p14="http://schemas.microsoft.com/office/powerpoint/2010/main" val="1024086991"/>
       </p:ext>
     </p:extLst>
   </p:cSld>
@@ -283,6 +502,10 @@
           <a:bodyPr/>
           <a:lstStyle/>
           <a:p>
+            <a:r>
+              <a:rPr lang="en-US" dirty="0"/>
+              <a:t/>
+            </a:r>
             <a:endParaRPr lang="en-US" dirty="0"/>
           </a:p>
         </p:txBody>
@@ -367,6 +590,10 @@
           <a:bodyPr/>
           <a:lstStyle/>
           <a:p>
+            <a:r>
+              <a:rPr lang="en-US" dirty="0"/>
+              <a:t/>
+            </a:r>
             <a:endParaRPr lang="en-US" dirty="0"/>
           </a:p>
         </p:txBody>
@@ -451,6 +678,10 @@
           <a:bodyPr/>
           <a:lstStyle/>
           <a:p>
+            <a:r>
+              <a:rPr lang="en-US" dirty="0"/>
+              <a:t/>
+            </a:r>
             <a:endParaRPr lang="en-US" dirty="0"/>
           </a:p>
         </p:txBody>
@@ -524,11 +755,6 @@
 <file path=ppt/slideMasters/slideMaster1.xml><?xml version="1.0" encoding="utf-8"?>
 <p:sldMaster xmlns:a="http://schemas.openxmlformats.org/drawingml/2006/main" xmlns:r="http://schemas.openxmlformats.org/officeDocument/2006/relationships" xmlns:p="http://schemas.openxmlformats.org/presentationml/2006/main">
   <p:cSld>
-    <p:bg>
-      <p:bgRef idx="1001">
-        <a:schemeClr val="bg1"/>
-      </p:bgRef>
-    </p:bg>
     <p:spTree>
       <p:nvGrpSpPr>
         <p:cNvPr id="1" name=""/>
@@ -811,7 +1037,6 @@
         <a:solidFill>
           <a:srgbClr val="0D1B2A"/>
         </a:solidFill>
-        <a:effectLst/>
       </p:bgPr>
     </p:bg>
     <p:spTree>
@@ -852,13 +1077,6 @@
             <a:prstDash val="solid"/>
           </a:ln>
         </p:spPr>
-        <p:txBody>
-          <a:bodyPr/>
-          <a:lstStyle/>
-          <a:p>
-            <a:endParaRPr lang="it-IT"/>
-          </a:p>
-        </p:txBody>
       </p:sp>
       <p:sp>
         <p:nvSpPr>
@@ -881,7 +1099,7 @@
           <a:bodyPr wrap="square" lIns="0" tIns="0" rIns="0" bIns="0" rtlCol="0" anchor="ctr"/>
           <a:lstStyle/>
           <a:p>
-            <a:pPr marL="0" indent="0" algn="l">
+            <a:pPr algn="l" indent="0" marL="0">
               <a:buNone/>
             </a:pPr>
             <a:r>
@@ -920,7 +1138,7 @@
           <a:bodyPr wrap="square" lIns="0" tIns="0" rIns="0" bIns="0" rtlCol="0" anchor="ctr"/>
           <a:lstStyle/>
           <a:p>
-            <a:pPr marL="0" indent="0" algn="l">
+            <a:pPr algn="l" indent="0" marL="0">
               <a:buNone/>
             </a:pPr>
             <a:r>
@@ -964,13 +1182,6 @@
             <a:prstDash val="solid"/>
           </a:ln>
         </p:spPr>
-        <p:txBody>
-          <a:bodyPr/>
-          <a:lstStyle/>
-          <a:p>
-            <a:endParaRPr lang="it-IT"/>
-          </a:p>
-        </p:txBody>
       </p:sp>
       <p:sp>
         <p:nvSpPr>
@@ -993,7 +1204,7 @@
           <a:bodyPr wrap="square" lIns="0" tIns="0" rIns="0" bIns="0" rtlCol="0" anchor="ctr"/>
           <a:lstStyle/>
           <a:p>
-            <a:pPr marL="0" indent="0" algn="l">
+            <a:pPr algn="l" indent="0" marL="0">
               <a:buNone/>
             </a:pPr>
             <a:r>
@@ -1032,7 +1243,7 @@
           <a:bodyPr wrap="square" lIns="0" tIns="0" rIns="0" bIns="0" rtlCol="0" anchor="ctr"/>
           <a:lstStyle/>
           <a:p>
-            <a:pPr marL="0" indent="0" algn="l">
+            <a:pPr algn="l" indent="0" marL="0">
               <a:buNone/>
             </a:pPr>
             <a:r>
@@ -1076,13 +1287,6 @@
             <a:prstDash val="solid"/>
           </a:ln>
         </p:spPr>
-        <p:txBody>
-          <a:bodyPr/>
-          <a:lstStyle/>
-          <a:p>
-            <a:endParaRPr lang="it-IT"/>
-          </a:p>
-        </p:txBody>
       </p:sp>
       <p:sp>
         <p:nvSpPr>
@@ -1105,7 +1309,7 @@
           <a:bodyPr wrap="square" lIns="0" tIns="0" rIns="0" bIns="0" rtlCol="0" anchor="ctr"/>
           <a:lstStyle/>
           <a:p>
-            <a:pPr marL="0" indent="0" algn="l">
+            <a:pPr algn="l" indent="0" marL="0">
               <a:buNone/>
             </a:pPr>
             <a:r>
@@ -1144,7 +1348,7 @@
           <a:bodyPr wrap="square" lIns="0" tIns="0" rIns="0" bIns="0" rtlCol="0" anchor="ctr"/>
           <a:lstStyle/>
           <a:p>
-            <a:pPr marL="0" indent="0" algn="l">
+            <a:pPr algn="l" indent="0" marL="0">
               <a:buNone/>
             </a:pPr>
             <a:r>
@@ -1183,7 +1387,7 @@
           <a:bodyPr wrap="square" lIns="0" tIns="0" rIns="0" bIns="0" rtlCol="0" anchor="ctr"/>
           <a:lstStyle/>
           <a:p>
-            <a:pPr marL="0" indent="0" algn="l">
+            <a:pPr algn="l" indent="0" marL="0">
               <a:buNone/>
             </a:pPr>
             <a:r>
@@ -1227,13 +1431,6 @@
             <a:prstDash val="solid"/>
           </a:ln>
         </p:spPr>
-        <p:txBody>
-          <a:bodyPr/>
-          <a:lstStyle/>
-          <a:p>
-            <a:endParaRPr lang="it-IT"/>
-          </a:p>
-        </p:txBody>
       </p:sp>
       <p:sp>
         <p:nvSpPr>
@@ -1256,7 +1453,7 @@
           <a:bodyPr wrap="square" lIns="0" tIns="0" rIns="0" bIns="0" rtlCol="0" anchor="ctr"/>
           <a:lstStyle/>
           <a:p>
-            <a:pPr marL="0" indent="0" algn="l">
+            <a:pPr algn="l" indent="0" marL="0">
               <a:buNone/>
             </a:pPr>
             <a:r>
@@ -1300,13 +1497,6 @@
             <a:prstDash val="solid"/>
           </a:ln>
         </p:spPr>
-        <p:txBody>
-          <a:bodyPr/>
-          <a:lstStyle/>
-          <a:p>
-            <a:endParaRPr lang="it-IT"/>
-          </a:p>
-        </p:txBody>
       </p:sp>
       <p:sp>
         <p:nvSpPr>
@@ -1329,7 +1519,7 @@
           <a:bodyPr wrap="square" lIns="0" tIns="0" rIns="0" bIns="0" rtlCol="0" anchor="ctr"/>
           <a:lstStyle/>
           <a:p>
-            <a:pPr marL="0" indent="0" algn="l">
+            <a:pPr algn="l" indent="0" marL="0">
               <a:buNone/>
             </a:pPr>
             <a:r>
@@ -1373,13 +1563,6 @@
             <a:prstDash val="solid"/>
           </a:ln>
         </p:spPr>
-        <p:txBody>
-          <a:bodyPr/>
-          <a:lstStyle/>
-          <a:p>
-            <a:endParaRPr lang="it-IT"/>
-          </a:p>
-        </p:txBody>
       </p:sp>
       <p:sp>
         <p:nvSpPr>
@@ -1402,7 +1585,7 @@
           <a:bodyPr wrap="square" lIns="0" tIns="0" rIns="0" bIns="0" rtlCol="0" anchor="ctr"/>
           <a:lstStyle/>
           <a:p>
-            <a:pPr marL="0" indent="0" algn="l">
+            <a:pPr algn="l" indent="0" marL="0">
               <a:buNone/>
             </a:pPr>
             <a:r>
@@ -1446,13 +1629,6 @@
             <a:prstDash val="solid"/>
           </a:ln>
         </p:spPr>
-        <p:txBody>
-          <a:bodyPr/>
-          <a:lstStyle/>
-          <a:p>
-            <a:endParaRPr lang="it-IT"/>
-          </a:p>
-        </p:txBody>
       </p:sp>
       <p:sp>
         <p:nvSpPr>
@@ -1475,7 +1651,7 @@
           <a:bodyPr wrap="square" lIns="0" tIns="0" rIns="0" bIns="0" rtlCol="0" anchor="ctr"/>
           <a:lstStyle/>
           <a:p>
-            <a:pPr marL="0" indent="0" algn="l">
+            <a:pPr algn="l" indent="0" marL="0">
               <a:buNone/>
             </a:pPr>
             <a:r>
@@ -1514,7 +1690,7 @@
           <a:bodyPr wrap="square" lIns="0" tIns="0" rIns="0" bIns="0" rtlCol="0" anchor="ctr"/>
           <a:lstStyle/>
           <a:p>
-            <a:pPr marL="0" indent="0" algn="l">
+            <a:pPr algn="l" indent="0" marL="0">
               <a:buNone/>
             </a:pPr>
             <a:r>
@@ -1548,7 +1724,6 @@
         <a:solidFill>
           <a:srgbClr val="F0F6FC"/>
         </a:solidFill>
-        <a:effectLst/>
       </p:bgPr>
     </p:bg>
     <p:spTree>
@@ -1589,13 +1764,6 @@
             <a:prstDash val="solid"/>
           </a:ln>
         </p:spPr>
-        <p:txBody>
-          <a:bodyPr/>
-          <a:lstStyle/>
-          <a:p>
-            <a:endParaRPr lang="it-IT"/>
-          </a:p>
-        </p:txBody>
       </p:sp>
       <p:sp>
         <p:nvSpPr>
@@ -1618,7 +1786,7 @@
           <a:bodyPr wrap="square" lIns="0" tIns="0" rIns="0" bIns="0" rtlCol="0" anchor="ctr"/>
           <a:lstStyle/>
           <a:p>
-            <a:pPr marL="0" indent="0" algn="l">
+            <a:pPr algn="l" indent="0" marL="0">
               <a:buNone/>
             </a:pPr>
             <a:r>
@@ -1662,20 +1830,13 @@
             <a:prstDash val="solid"/>
           </a:ln>
           <a:effectLst>
-            <a:outerShdw blurRad="76200" dist="25400" dir="2700000" algn="bl" rotWithShape="0">
+            <a:outerShdw sx="100000" sy="100000" kx="0" ky="0" algn="bl" rotWithShape="0" blurRad="76200" dist="25400" dir="2700000">
               <a:srgbClr val="000000">
                 <a:alpha val="8000"/>
               </a:srgbClr>
             </a:outerShdw>
           </a:effectLst>
         </p:spPr>
-        <p:txBody>
-          <a:bodyPr/>
-          <a:lstStyle/>
-          <a:p>
-            <a:endParaRPr lang="it-IT"/>
-          </a:p>
-        </p:txBody>
       </p:sp>
       <p:sp>
         <p:nvSpPr>
@@ -1701,13 +1862,6 @@
             <a:prstDash val="solid"/>
           </a:ln>
         </p:spPr>
-        <p:txBody>
-          <a:bodyPr/>
-          <a:lstStyle/>
-          <a:p>
-            <a:endParaRPr lang="it-IT"/>
-          </a:p>
-        </p:txBody>
       </p:sp>
       <p:sp>
         <p:nvSpPr>
@@ -1730,7 +1884,7 @@
           <a:bodyPr wrap="square" lIns="0" tIns="0" rIns="0" bIns="0" rtlCol="0" anchor="ctr"/>
           <a:lstStyle/>
           <a:p>
-            <a:pPr marL="0" indent="0" algn="ctr">
+            <a:pPr algn="ctr" indent="0" marL="0">
               <a:buNone/>
             </a:pPr>
             <a:r>
@@ -1769,7 +1923,7 @@
           <a:bodyPr wrap="square" lIns="0" tIns="0" rIns="0" bIns="0" rtlCol="0" anchor="ctr"/>
           <a:lstStyle/>
           <a:p>
-            <a:pPr marL="0" indent="0" algn="l">
+            <a:pPr algn="l" indent="0" marL="0">
               <a:buNone/>
             </a:pPr>
             <a:r>
@@ -1808,7 +1962,7 @@
           <a:bodyPr wrap="square" lIns="0" tIns="0" rIns="0" bIns="0" rtlCol="0" anchor="ctr"/>
           <a:lstStyle/>
           <a:p>
-            <a:pPr marL="0" indent="0" algn="l">
+            <a:pPr algn="l" indent="0" marL="0">
               <a:buNone/>
             </a:pPr>
             <a:r>
@@ -1825,7 +1979,7 @@
             <a:endParaRPr lang="en-US" sz="1000" dirty="0"/>
           </a:p>
           <a:p>
-            <a:pPr marL="0" indent="0" algn="l">
+            <a:pPr algn="l" indent="0" marL="0">
               <a:buNone/>
             </a:pPr>
             <a:r>
@@ -1842,7 +1996,7 @@
             <a:endParaRPr lang="en-US" sz="1000" dirty="0"/>
           </a:p>
           <a:p>
-            <a:pPr marL="0" indent="0" algn="l">
+            <a:pPr algn="l" indent="0" marL="0">
               <a:buNone/>
             </a:pPr>
             <a:r>
@@ -1886,20 +2040,13 @@
             <a:prstDash val="solid"/>
           </a:ln>
           <a:effectLst>
-            <a:outerShdw blurRad="76200" dist="25400" dir="2700000" algn="bl" rotWithShape="0">
+            <a:outerShdw sx="100000" sy="100000" kx="0" ky="0" algn="bl" rotWithShape="0" blurRad="76200" dist="25400" dir="2700000">
               <a:srgbClr val="000000">
                 <a:alpha val="8000"/>
               </a:srgbClr>
             </a:outerShdw>
           </a:effectLst>
         </p:spPr>
-        <p:txBody>
-          <a:bodyPr/>
-          <a:lstStyle/>
-          <a:p>
-            <a:endParaRPr lang="it-IT"/>
-          </a:p>
-        </p:txBody>
       </p:sp>
       <p:sp>
         <p:nvSpPr>
@@ -1925,13 +2072,6 @@
             <a:prstDash val="solid"/>
           </a:ln>
         </p:spPr>
-        <p:txBody>
-          <a:bodyPr/>
-          <a:lstStyle/>
-          <a:p>
-            <a:endParaRPr lang="it-IT"/>
-          </a:p>
-        </p:txBody>
       </p:sp>
       <p:sp>
         <p:nvSpPr>
@@ -1954,7 +2094,7 @@
           <a:bodyPr wrap="square" lIns="0" tIns="0" rIns="0" bIns="0" rtlCol="0" anchor="ctr"/>
           <a:lstStyle/>
           <a:p>
-            <a:pPr marL="0" indent="0" algn="ctr">
+            <a:pPr algn="ctr" indent="0" marL="0">
               <a:buNone/>
             </a:pPr>
             <a:r>
@@ -1993,7 +2133,7 @@
           <a:bodyPr wrap="square" lIns="0" tIns="0" rIns="0" bIns="0" rtlCol="0" anchor="ctr"/>
           <a:lstStyle/>
           <a:p>
-            <a:pPr marL="0" indent="0" algn="l">
+            <a:pPr algn="l" indent="0" marL="0">
               <a:buNone/>
             </a:pPr>
             <a:r>
@@ -2032,7 +2172,7 @@
           <a:bodyPr wrap="square" lIns="0" tIns="0" rIns="0" bIns="0" rtlCol="0" anchor="ctr"/>
           <a:lstStyle/>
           <a:p>
-            <a:pPr marL="0" indent="0" algn="l">
+            <a:pPr algn="l" indent="0" marL="0">
               <a:buNone/>
             </a:pPr>
             <a:r>
@@ -2049,7 +2189,7 @@
             <a:endParaRPr lang="en-US" sz="1000" dirty="0"/>
           </a:p>
           <a:p>
-            <a:pPr marL="0" indent="0" algn="l">
+            <a:pPr algn="l" indent="0" marL="0">
               <a:buNone/>
             </a:pPr>
             <a:r>
@@ -2066,7 +2206,7 @@
             <a:endParaRPr lang="en-US" sz="1000" dirty="0"/>
           </a:p>
           <a:p>
-            <a:pPr marL="0" indent="0" algn="l">
+            <a:pPr algn="l" indent="0" marL="0">
               <a:buNone/>
             </a:pPr>
             <a:r>
@@ -2110,20 +2250,13 @@
             <a:prstDash val="solid"/>
           </a:ln>
           <a:effectLst>
-            <a:outerShdw blurRad="76200" dist="25400" dir="2700000" algn="bl" rotWithShape="0">
+            <a:outerShdw sx="100000" sy="100000" kx="0" ky="0" algn="bl" rotWithShape="0" blurRad="76200" dist="25400" dir="2700000">
               <a:srgbClr val="000000">
                 <a:alpha val="8000"/>
               </a:srgbClr>
             </a:outerShdw>
           </a:effectLst>
         </p:spPr>
-        <p:txBody>
-          <a:bodyPr/>
-          <a:lstStyle/>
-          <a:p>
-            <a:endParaRPr lang="it-IT"/>
-          </a:p>
-        </p:txBody>
       </p:sp>
       <p:sp>
         <p:nvSpPr>
@@ -2149,13 +2282,6 @@
             <a:prstDash val="solid"/>
           </a:ln>
         </p:spPr>
-        <p:txBody>
-          <a:bodyPr/>
-          <a:lstStyle/>
-          <a:p>
-            <a:endParaRPr lang="it-IT"/>
-          </a:p>
-        </p:txBody>
       </p:sp>
       <p:sp>
         <p:nvSpPr>
@@ -2178,7 +2304,7 @@
           <a:bodyPr wrap="square" lIns="0" tIns="0" rIns="0" bIns="0" rtlCol="0" anchor="ctr"/>
           <a:lstStyle/>
           <a:p>
-            <a:pPr marL="0" indent="0" algn="ctr">
+            <a:pPr algn="ctr" indent="0" marL="0">
               <a:buNone/>
             </a:pPr>
             <a:r>
@@ -2217,7 +2343,7 @@
           <a:bodyPr wrap="square" lIns="0" tIns="0" rIns="0" bIns="0" rtlCol="0" anchor="ctr"/>
           <a:lstStyle/>
           <a:p>
-            <a:pPr marL="0" indent="0" algn="l">
+            <a:pPr algn="l" indent="0" marL="0">
               <a:buNone/>
             </a:pPr>
             <a:r>
@@ -2256,7 +2382,7 @@
           <a:bodyPr wrap="square" lIns="0" tIns="0" rIns="0" bIns="0" rtlCol="0" anchor="ctr"/>
           <a:lstStyle/>
           <a:p>
-            <a:pPr marL="0" indent="0" algn="l">
+            <a:pPr algn="l" indent="0" marL="0">
               <a:buNone/>
             </a:pPr>
             <a:r>
@@ -2273,7 +2399,7 @@
             <a:endParaRPr lang="en-US" sz="1000" dirty="0"/>
           </a:p>
           <a:p>
-            <a:pPr marL="0" indent="0" algn="l">
+            <a:pPr algn="l" indent="0" marL="0">
               <a:buNone/>
             </a:pPr>
             <a:r>
@@ -2290,7 +2416,7 @@
             <a:endParaRPr lang="en-US" sz="1000" dirty="0"/>
           </a:p>
           <a:p>
-            <a:pPr marL="0" indent="0" algn="l">
+            <a:pPr algn="l" indent="0" marL="0">
               <a:buNone/>
             </a:pPr>
             <a:r>
@@ -2334,20 +2460,13 @@
             <a:prstDash val="solid"/>
           </a:ln>
           <a:effectLst>
-            <a:outerShdw blurRad="76200" dist="25400" dir="2700000" algn="bl" rotWithShape="0">
+            <a:outerShdw sx="100000" sy="100000" kx="0" ky="0" algn="bl" rotWithShape="0" blurRad="76200" dist="25400" dir="2700000">
               <a:srgbClr val="000000">
                 <a:alpha val="8000"/>
               </a:srgbClr>
             </a:outerShdw>
           </a:effectLst>
         </p:spPr>
-        <p:txBody>
-          <a:bodyPr/>
-          <a:lstStyle/>
-          <a:p>
-            <a:endParaRPr lang="it-IT"/>
-          </a:p>
-        </p:txBody>
       </p:sp>
       <p:sp>
         <p:nvSpPr>
@@ -2373,13 +2492,6 @@
             <a:prstDash val="solid"/>
           </a:ln>
         </p:spPr>
-        <p:txBody>
-          <a:bodyPr/>
-          <a:lstStyle/>
-          <a:p>
-            <a:endParaRPr lang="it-IT"/>
-          </a:p>
-        </p:txBody>
       </p:sp>
       <p:sp>
         <p:nvSpPr>
@@ -2402,7 +2514,7 @@
           <a:bodyPr wrap="square" lIns="0" tIns="0" rIns="0" bIns="0" rtlCol="0" anchor="ctr"/>
           <a:lstStyle/>
           <a:p>
-            <a:pPr marL="0" indent="0" algn="ctr">
+            <a:pPr algn="ctr" indent="0" marL="0">
               <a:buNone/>
             </a:pPr>
             <a:r>
@@ -2441,7 +2553,7 @@
           <a:bodyPr wrap="square" lIns="0" tIns="0" rIns="0" bIns="0" rtlCol="0" anchor="ctr"/>
           <a:lstStyle/>
           <a:p>
-            <a:pPr marL="0" indent="0" algn="l">
+            <a:pPr algn="l" indent="0" marL="0">
               <a:buNone/>
             </a:pPr>
             <a:r>
@@ -2480,7 +2592,7 @@
           <a:bodyPr wrap="square" lIns="0" tIns="0" rIns="0" bIns="0" rtlCol="0" anchor="ctr"/>
           <a:lstStyle/>
           <a:p>
-            <a:pPr marL="0" indent="0" algn="l">
+            <a:pPr algn="l" indent="0" marL="0">
               <a:buNone/>
             </a:pPr>
             <a:r>
@@ -2497,7 +2609,7 @@
             <a:endParaRPr lang="en-US" sz="1000" dirty="0"/>
           </a:p>
           <a:p>
-            <a:pPr marL="0" indent="0" algn="l">
+            <a:pPr algn="l" indent="0" marL="0">
               <a:buNone/>
             </a:pPr>
             <a:r>
@@ -2514,7 +2626,7 @@
             <a:endParaRPr lang="en-US" sz="1000" dirty="0"/>
           </a:p>
           <a:p>
-            <a:pPr marL="0" indent="0" algn="l">
+            <a:pPr algn="l" indent="0" marL="0">
               <a:buNone/>
             </a:pPr>
             <a:r>
@@ -2558,20 +2670,13 @@
             <a:prstDash val="solid"/>
           </a:ln>
           <a:effectLst>
-            <a:outerShdw blurRad="76200" dist="25400" dir="2700000" algn="bl" rotWithShape="0">
+            <a:outerShdw sx="100000" sy="100000" kx="0" ky="0" algn="bl" rotWithShape="0" blurRad="76200" dist="25400" dir="2700000">
               <a:srgbClr val="000000">
                 <a:alpha val="8000"/>
               </a:srgbClr>
             </a:outerShdw>
           </a:effectLst>
         </p:spPr>
-        <p:txBody>
-          <a:bodyPr/>
-          <a:lstStyle/>
-          <a:p>
-            <a:endParaRPr lang="it-IT"/>
-          </a:p>
-        </p:txBody>
       </p:sp>
       <p:sp>
         <p:nvSpPr>
@@ -2597,13 +2702,6 @@
             <a:prstDash val="solid"/>
           </a:ln>
         </p:spPr>
-        <p:txBody>
-          <a:bodyPr/>
-          <a:lstStyle/>
-          <a:p>
-            <a:endParaRPr lang="it-IT"/>
-          </a:p>
-        </p:txBody>
       </p:sp>
       <p:sp>
         <p:nvSpPr>
@@ -2626,7 +2724,7 @@
           <a:bodyPr wrap="square" lIns="0" tIns="0" rIns="0" bIns="0" rtlCol="0" anchor="ctr"/>
           <a:lstStyle/>
           <a:p>
-            <a:pPr marL="0" indent="0" algn="ctr">
+            <a:pPr algn="ctr" indent="0" marL="0">
               <a:buNone/>
             </a:pPr>
             <a:r>
@@ -2665,7 +2763,7 @@
           <a:bodyPr wrap="square" lIns="0" tIns="0" rIns="0" bIns="0" rtlCol="0" anchor="ctr"/>
           <a:lstStyle/>
           <a:p>
-            <a:pPr marL="0" indent="0" algn="l">
+            <a:pPr algn="l" indent="0" marL="0">
               <a:buNone/>
             </a:pPr>
             <a:r>
@@ -2677,7 +2775,7 @@
                 <a:ea typeface="Calibri" pitchFamily="34" charset="-122"/>
                 <a:cs typeface="Calibri" pitchFamily="34" charset="-120"/>
               </a:rPr>
-              <a:t>Regression</a:t>
+              <a:t>Hypothesis Test</a:t>
             </a:r>
             <a:endParaRPr lang="en-US" sz="1200" dirty="0"/>
           </a:p>
@@ -2704,7 +2802,7 @@
           <a:bodyPr wrap="square" lIns="0" tIns="0" rIns="0" bIns="0" rtlCol="0" anchor="ctr"/>
           <a:lstStyle/>
           <a:p>
-            <a:pPr marL="0" indent="0" algn="l">
+            <a:pPr algn="l" indent="0" marL="0">
               <a:buNone/>
             </a:pPr>
             <a:r>
@@ -2716,12 +2814,12 @@
                 <a:ea typeface="Calibri" pitchFamily="34" charset="-122"/>
                 <a:cs typeface="Calibri" pitchFamily="34" charset="-120"/>
               </a:rPr>
-              <a:t>Linear Regression: R²=0.87</a:t>
+              <a:t>One-way ANOVA across 3 clusters</a:t>
             </a:r>
             <a:endParaRPr lang="en-US" sz="1000" dirty="0"/>
           </a:p>
           <a:p>
-            <a:pPr marL="0" indent="0" algn="l">
+            <a:pPr algn="l" indent="0" marL="0">
               <a:buNone/>
             </a:pPr>
             <a:r>
@@ -2733,12 +2831,12 @@
                 <a:ea typeface="Calibri" pitchFamily="34" charset="-122"/>
                 <a:cs typeface="Calibri" pitchFamily="34" charset="-120"/>
               </a:rPr>
-              <a:t>MAPE=96% on filtered dataset</a:t>
+              <a:t>Tukey HSD post-hoc test</a:t>
             </a:r>
             <a:endParaRPr lang="en-US" sz="1000" dirty="0"/>
           </a:p>
           <a:p>
-            <a:pPr marL="0" indent="0" algn="l">
+            <a:pPr algn="l" indent="0" marL="0">
               <a:buNone/>
             </a:pPr>
             <a:r>
@@ -2750,7 +2848,7 @@
                 <a:ea typeface="Calibri" pitchFamily="34" charset="-122"/>
                 <a:cs typeface="Calibri" pitchFamily="34" charset="-120"/>
               </a:rPr>
-              <a:t>COVID year excluded from training</a:t>
+              <a:t>Validates cluster segmentation</a:t>
             </a:r>
             <a:endParaRPr lang="en-US" sz="1000" dirty="0"/>
           </a:p>
@@ -2782,20 +2880,13 @@
             <a:prstDash val="solid"/>
           </a:ln>
           <a:effectLst>
-            <a:outerShdw blurRad="76200" dist="25400" dir="2700000" algn="bl" rotWithShape="0">
+            <a:outerShdw sx="100000" sy="100000" kx="0" ky="0" algn="bl" rotWithShape="0" blurRad="76200" dist="25400" dir="2700000">
               <a:srgbClr val="000000">
                 <a:alpha val="8000"/>
               </a:srgbClr>
             </a:outerShdw>
           </a:effectLst>
         </p:spPr>
-        <p:txBody>
-          <a:bodyPr/>
-          <a:lstStyle/>
-          <a:p>
-            <a:endParaRPr lang="it-IT"/>
-          </a:p>
-        </p:txBody>
       </p:sp>
       <p:sp>
         <p:nvSpPr>
@@ -2821,13 +2912,6 @@
             <a:prstDash val="solid"/>
           </a:ln>
         </p:spPr>
-        <p:txBody>
-          <a:bodyPr/>
-          <a:lstStyle/>
-          <a:p>
-            <a:endParaRPr lang="it-IT"/>
-          </a:p>
-        </p:txBody>
       </p:sp>
       <p:sp>
         <p:nvSpPr>
@@ -2850,7 +2934,7 @@
           <a:bodyPr wrap="square" lIns="0" tIns="0" rIns="0" bIns="0" rtlCol="0" anchor="ctr"/>
           <a:lstStyle/>
           <a:p>
-            <a:pPr marL="0" indent="0" algn="ctr">
+            <a:pPr algn="ctr" indent="0" marL="0">
               <a:buNone/>
             </a:pPr>
             <a:r>
@@ -2889,7 +2973,7 @@
           <a:bodyPr wrap="square" lIns="0" tIns="0" rIns="0" bIns="0" rtlCol="0" anchor="ctr"/>
           <a:lstStyle/>
           <a:p>
-            <a:pPr marL="0" indent="0" algn="l">
+            <a:pPr algn="l" indent="0" marL="0">
               <a:buNone/>
             </a:pPr>
             <a:r>
@@ -2901,7 +2985,7 @@
                 <a:ea typeface="Calibri" pitchFamily="34" charset="-122"/>
                 <a:cs typeface="Calibri" pitchFamily="34" charset="-120"/>
               </a:rPr>
-              <a:t>Predictions</a:t>
+              <a:t>Regression</a:t>
             </a:r>
             <a:endParaRPr lang="en-US" sz="1200" dirty="0"/>
           </a:p>
@@ -2928,7 +3012,7 @@
           <a:bodyPr wrap="square" lIns="0" tIns="0" rIns="0" bIns="0" rtlCol="0" anchor="ctr"/>
           <a:lstStyle/>
           <a:p>
-            <a:pPr marL="0" indent="0" algn="l">
+            <a:pPr algn="l" indent="0" marL="0">
               <a:buNone/>
             </a:pPr>
             <a:r>
@@ -2940,41 +3024,41 @@
                 <a:ea typeface="Calibri" pitchFamily="34" charset="-122"/>
                 <a:cs typeface="Calibri" pitchFamily="34" charset="-120"/>
               </a:rPr>
+              <a:t>Linear Regression: R²=0.87</a:t>
+            </a:r>
+            <a:endParaRPr lang="en-US" sz="1000" dirty="0"/>
+          </a:p>
+          <a:p>
+            <a:pPr algn="l" indent="0" marL="0">
+              <a:buNone/>
+            </a:pPr>
+            <a:r>
+              <a:rPr lang="en-US" sz="1000" dirty="0">
+                <a:solidFill>
+                  <a:srgbClr val="334E68"/>
+                </a:solidFill>
+                <a:latin typeface="Calibri" pitchFamily="34" charset="0"/>
+                <a:ea typeface="Calibri" pitchFamily="34" charset="-122"/>
+                <a:cs typeface="Calibri" pitchFamily="34" charset="-120"/>
+              </a:rPr>
+              <a:t>MAPE=96% — COVID year excluded</a:t>
+            </a:r>
+            <a:endParaRPr lang="en-US" sz="1000" dirty="0"/>
+          </a:p>
+          <a:p>
+            <a:pPr algn="l" indent="0" marL="0">
+              <a:buNone/>
+            </a:pPr>
+            <a:r>
+              <a:rPr lang="en-US" sz="1000" dirty="0">
+                <a:solidFill>
+                  <a:srgbClr val="334E68"/>
+                </a:solidFill>
+                <a:latin typeface="Calibri" pitchFamily="34" charset="0"/>
+                <a:ea typeface="Calibri" pitchFamily="34" charset="-122"/>
+                <a:cs typeface="Calibri" pitchFamily="34" charset="-120"/>
+              </a:rPr>
               <a:t>2025–2027 accident forecasts</a:t>
-            </a:r>
-            <a:endParaRPr lang="en-US" sz="1000" dirty="0"/>
-          </a:p>
-          <a:p>
-            <a:pPr marL="0" indent="0" algn="l">
-              <a:buNone/>
-            </a:pPr>
-            <a:r>
-              <a:rPr lang="en-US" sz="1000" dirty="0">
-                <a:solidFill>
-                  <a:srgbClr val="334E68"/>
-                </a:solidFill>
-                <a:latin typeface="Calibri" pitchFamily="34" charset="0"/>
-                <a:ea typeface="Calibri" pitchFamily="34" charset="-122"/>
-                <a:cs typeface="Calibri" pitchFamily="34" charset="-120"/>
-              </a:rPr>
-              <a:t>Per municipality, top at-risk cities</a:t>
-            </a:r>
-            <a:endParaRPr lang="en-US" sz="1000" dirty="0"/>
-          </a:p>
-          <a:p>
-            <a:pPr marL="0" indent="0" algn="l">
-              <a:buNone/>
-            </a:pPr>
-            <a:r>
-              <a:rPr lang="en-US" sz="1000" dirty="0">
-                <a:solidFill>
-                  <a:srgbClr val="334E68"/>
-                </a:solidFill>
-                <a:latin typeface="Calibri" pitchFamily="34" charset="0"/>
-                <a:ea typeface="Calibri" pitchFamily="34" charset="-122"/>
-                <a:cs typeface="Calibri" pitchFamily="34" charset="-120"/>
-              </a:rPr>
-              <a:t>Supports investment decisions</a:t>
             </a:r>
             <a:endParaRPr lang="en-US" sz="1000" dirty="0"/>
           </a:p>
@@ -3001,7 +3085,7 @@
           <a:bodyPr wrap="square" lIns="0" tIns="0" rIns="0" bIns="0" rtlCol="0" anchor="ctr"/>
           <a:lstStyle/>
           <a:p>
-            <a:pPr marL="0" indent="0" algn="l">
+            <a:pPr algn="l" indent="0" marL="0">
               <a:buNone/>
             </a:pPr>
             <a:r>
@@ -3035,7 +3119,6 @@
         <a:solidFill>
           <a:srgbClr val="0D1B2A"/>
         </a:solidFill>
-        <a:effectLst/>
       </p:bgPr>
     </p:bg>
     <p:spTree>
@@ -3076,13 +3159,6 @@
             <a:prstDash val="solid"/>
           </a:ln>
         </p:spPr>
-        <p:txBody>
-          <a:bodyPr/>
-          <a:lstStyle/>
-          <a:p>
-            <a:endParaRPr lang="it-IT"/>
-          </a:p>
-        </p:txBody>
       </p:sp>
       <p:sp>
         <p:nvSpPr>
@@ -3105,7 +3181,7 @@
           <a:bodyPr wrap="square" lIns="0" tIns="0" rIns="0" bIns="0" rtlCol="0" anchor="ctr"/>
           <a:lstStyle/>
           <a:p>
-            <a:pPr marL="0" indent="0" algn="l">
+            <a:pPr algn="l" indent="0" marL="0">
               <a:buNone/>
             </a:pPr>
             <a:r>
@@ -3149,13 +3225,6 @@
             <a:prstDash val="solid"/>
           </a:ln>
         </p:spPr>
-        <p:txBody>
-          <a:bodyPr/>
-          <a:lstStyle/>
-          <a:p>
-            <a:endParaRPr lang="it-IT"/>
-          </a:p>
-        </p:txBody>
       </p:sp>
       <p:sp>
         <p:nvSpPr>
@@ -3178,7 +3247,7 @@
           <a:bodyPr wrap="square" lIns="0" tIns="0" rIns="0" bIns="0" rtlCol="0" anchor="ctr"/>
           <a:lstStyle/>
           <a:p>
-            <a:pPr marL="0" indent="0" algn="l">
+            <a:pPr algn="l" indent="0" marL="0">
               <a:buNone/>
             </a:pPr>
             <a:r>
@@ -3217,7 +3286,7 @@
           <a:bodyPr wrap="square" lIns="0" tIns="0" rIns="0" bIns="0" rtlCol="0" anchor="ctr"/>
           <a:lstStyle/>
           <a:p>
-            <a:pPr marL="0" indent="0" algn="l">
+            <a:pPr algn="l" indent="0" marL="0">
               <a:buNone/>
             </a:pPr>
             <a:r>
@@ -3256,7 +3325,7 @@
           <a:bodyPr wrap="square" lIns="0" tIns="0" rIns="0" bIns="0" rtlCol="0" anchor="ctr"/>
           <a:lstStyle/>
           <a:p>
-            <a:pPr marL="0" indent="0" algn="l">
+            <a:pPr algn="l" indent="0" marL="0">
               <a:buNone/>
             </a:pPr>
             <a:r>
@@ -3295,7 +3364,7 @@
           <a:bodyPr wrap="square" lIns="0" tIns="0" rIns="0" bIns="0" rtlCol="0" anchor="ctr"/>
           <a:lstStyle/>
           <a:p>
-            <a:pPr marL="0" indent="0" algn="l">
+            <a:pPr algn="l" indent="0" marL="0">
               <a:buNone/>
             </a:pPr>
             <a:r>
@@ -3339,13 +3408,6 @@
             <a:prstDash val="solid"/>
           </a:ln>
         </p:spPr>
-        <p:txBody>
-          <a:bodyPr/>
-          <a:lstStyle/>
-          <a:p>
-            <a:endParaRPr lang="it-IT"/>
-          </a:p>
-        </p:txBody>
       </p:sp>
       <p:sp>
         <p:nvSpPr>
@@ -3368,7 +3430,7 @@
           <a:bodyPr wrap="square" lIns="0" tIns="0" rIns="0" bIns="0" rtlCol="0" anchor="ctr"/>
           <a:lstStyle/>
           <a:p>
-            <a:pPr marL="0" indent="0" algn="l">
+            <a:pPr algn="l" indent="0" marL="0">
               <a:buNone/>
             </a:pPr>
             <a:r>
@@ -3407,7 +3469,7 @@
           <a:bodyPr wrap="square" lIns="0" tIns="0" rIns="0" bIns="0" rtlCol="0" anchor="ctr"/>
           <a:lstStyle/>
           <a:p>
-            <a:pPr marL="0" indent="0" algn="l">
+            <a:pPr algn="l" indent="0" marL="0">
               <a:buNone/>
             </a:pPr>
             <a:r>
@@ -3446,7 +3508,7 @@
           <a:bodyPr wrap="square" lIns="0" tIns="0" rIns="0" bIns="0" rtlCol="0" anchor="ctr"/>
           <a:lstStyle/>
           <a:p>
-            <a:pPr marL="0" indent="0" algn="l">
+            <a:pPr algn="l" indent="0" marL="0">
               <a:buNone/>
             </a:pPr>
             <a:r>
@@ -3485,7 +3547,7 @@
           <a:bodyPr wrap="square" lIns="0" tIns="0" rIns="0" bIns="0" rtlCol="0" anchor="ctr"/>
           <a:lstStyle/>
           <a:p>
-            <a:pPr marL="0" indent="0" algn="l">
+            <a:pPr algn="l" indent="0" marL="0">
               <a:buNone/>
             </a:pPr>
             <a:r>
@@ -3529,13 +3591,6 @@
             <a:prstDash val="solid"/>
           </a:ln>
         </p:spPr>
-        <p:txBody>
-          <a:bodyPr/>
-          <a:lstStyle/>
-          <a:p>
-            <a:endParaRPr lang="it-IT"/>
-          </a:p>
-        </p:txBody>
       </p:sp>
       <p:sp>
         <p:nvSpPr>
@@ -3558,7 +3613,7 @@
           <a:bodyPr wrap="square" lIns="0" tIns="0" rIns="0" bIns="0" rtlCol="0" anchor="ctr"/>
           <a:lstStyle/>
           <a:p>
-            <a:pPr marL="0" indent="0" algn="l">
+            <a:pPr algn="l" indent="0" marL="0">
               <a:buNone/>
             </a:pPr>
             <a:r>
@@ -3597,7 +3652,7 @@
           <a:bodyPr wrap="square" lIns="0" tIns="0" rIns="0" bIns="0" rtlCol="0" anchor="ctr"/>
           <a:lstStyle/>
           <a:p>
-            <a:pPr marL="0" indent="0" algn="l">
+            <a:pPr algn="l" indent="0" marL="0">
               <a:buNone/>
             </a:pPr>
             <a:r>
@@ -3636,7 +3691,7 @@
           <a:bodyPr wrap="square" lIns="0" tIns="0" rIns="0" bIns="0" rtlCol="0" anchor="ctr"/>
           <a:lstStyle/>
           <a:p>
-            <a:pPr marL="0" indent="0" algn="l">
+            <a:pPr algn="l" indent="0" marL="0">
               <a:buNone/>
             </a:pPr>
             <a:r>
@@ -3675,7 +3730,7 @@
           <a:bodyPr wrap="square" lIns="0" tIns="0" rIns="0" bIns="0" rtlCol="0" anchor="ctr"/>
           <a:lstStyle/>
           <a:p>
-            <a:pPr marL="0" indent="0" algn="l">
+            <a:pPr algn="l" indent="0" marL="0">
               <a:buNone/>
             </a:pPr>
             <a:r>
@@ -3719,13 +3774,6 @@
             <a:prstDash val="solid"/>
           </a:ln>
         </p:spPr>
-        <p:txBody>
-          <a:bodyPr/>
-          <a:lstStyle/>
-          <a:p>
-            <a:endParaRPr lang="it-IT"/>
-          </a:p>
-        </p:txBody>
       </p:sp>
       <p:sp>
         <p:nvSpPr>
@@ -3748,7 +3796,7 @@
           <a:bodyPr wrap="square" lIns="0" tIns="0" rIns="0" bIns="0" rtlCol="0" anchor="ctr"/>
           <a:lstStyle/>
           <a:p>
-            <a:pPr marL="0" indent="0" algn="l">
+            <a:pPr algn="l" indent="0" marL="0">
               <a:buNone/>
             </a:pPr>
             <a:r>
@@ -3787,7 +3835,7 @@
           <a:bodyPr wrap="square" lIns="0" tIns="0" rIns="0" bIns="0" rtlCol="0" anchor="ctr"/>
           <a:lstStyle/>
           <a:p>
-            <a:pPr marL="0" indent="0" algn="l">
+            <a:pPr algn="l" indent="0" marL="0">
               <a:buNone/>
             </a:pPr>
             <a:r>
@@ -3826,7 +3874,7 @@
           <a:bodyPr wrap="square" lIns="0" tIns="0" rIns="0" bIns="0" rtlCol="0" anchor="ctr"/>
           <a:lstStyle/>
           <a:p>
-            <a:pPr marL="0" indent="0" algn="l">
+            <a:pPr algn="l" indent="0" marL="0">
               <a:buNone/>
             </a:pPr>
             <a:r>
@@ -3865,7 +3913,7 @@
           <a:bodyPr wrap="square" lIns="0" tIns="0" rIns="0" bIns="0" rtlCol="0" anchor="ctr"/>
           <a:lstStyle/>
           <a:p>
-            <a:pPr marL="0" indent="0" algn="l">
+            <a:pPr algn="l" indent="0" marL="0">
               <a:buNone/>
             </a:pPr>
             <a:r>
@@ -3904,7 +3952,7 @@
           <a:bodyPr wrap="square" lIns="0" tIns="0" rIns="0" bIns="0" rtlCol="0" anchor="ctr"/>
           <a:lstStyle/>
           <a:p>
-            <a:pPr marL="0" indent="0" algn="l">
+            <a:pPr algn="l" indent="0" marL="0">
               <a:buNone/>
             </a:pPr>
             <a:r>
@@ -4223,319 +4271,4 @@
     </a:ext>
   </a:extLst>
 </a:theme>
-</file>
-
-<file path=ppt/theme/theme2.xml><?xml version="1.0" encoding="utf-8"?>
-<a:theme xmlns:a="http://schemas.openxmlformats.org/drawingml/2006/main" name="Tema di Office">
-  <a:themeElements>
-    <a:clrScheme name="Office">
-      <a:dk1>
-        <a:sysClr val="windowText" lastClr="000000"/>
-      </a:dk1>
-      <a:lt1>
-        <a:sysClr val="window" lastClr="FFFFFF"/>
-      </a:lt1>
-      <a:dk2>
-        <a:srgbClr val="0E2841"/>
-      </a:dk2>
-      <a:lt2>
-        <a:srgbClr val="E8E8E8"/>
-      </a:lt2>
-      <a:accent1>
-        <a:srgbClr val="156082"/>
-      </a:accent1>
-      <a:accent2>
-        <a:srgbClr val="E97132"/>
-      </a:accent2>
-      <a:accent3>
-        <a:srgbClr val="196B24"/>
-      </a:accent3>
-      <a:accent4>
-        <a:srgbClr val="0F9ED5"/>
-      </a:accent4>
-      <a:accent5>
-        <a:srgbClr val="A02B93"/>
-      </a:accent5>
-      <a:accent6>
-        <a:srgbClr val="4EA72E"/>
-      </a:accent6>
-      <a:hlink>
-        <a:srgbClr val="467886"/>
-      </a:hlink>
-      <a:folHlink>
-        <a:srgbClr val="96607D"/>
-      </a:folHlink>
-    </a:clrScheme>
-    <a:fontScheme name="Office">
-      <a:majorFont>
-        <a:latin typeface="Aptos Display" panose="02110004020202020204"/>
-        <a:ea typeface=""/>
-        <a:cs typeface=""/>
-        <a:font script="Jpan" typeface="游ゴシック Light"/>
-        <a:font script="Hang" typeface="맑은 고딕"/>
-        <a:font script="Hans" typeface="等线 Light"/>
-        <a:font script="Hant" typeface="新細明體"/>
-        <a:font script="Arab" typeface="Times New Roman"/>
-        <a:font script="Hebr" typeface="Times New Roman"/>
-        <a:font script="Thai" typeface="Angsana New"/>
-        <a:font script="Ethi" typeface="Nyala"/>
-        <a:font script="Beng" typeface="Vrinda"/>
-        <a:font script="Gujr" typeface="Shruti"/>
-        <a:font script="Khmr" typeface="MoolBoran"/>
-        <a:font script="Knda" typeface="Tunga"/>
-        <a:font script="Guru" typeface="Raavi"/>
-        <a:font script="Cans" typeface="Euphemia"/>
-        <a:font script="Cher" typeface="Plantagenet Cherokee"/>
-        <a:font script="Yiii" typeface="Microsoft Yi Baiti"/>
-        <a:font script="Tibt" typeface="Microsoft Himalaya"/>
-        <a:font script="Thaa" typeface="MV Boli"/>
-        <a:font script="Deva" typeface="Mangal"/>
-        <a:font script="Telu" typeface="Gautami"/>
-        <a:font script="Taml" typeface="Latha"/>
-        <a:font script="Syrc" typeface="Estrangelo Edessa"/>
-        <a:font script="Orya" typeface="Kalinga"/>
-        <a:font script="Mlym" typeface="Kartika"/>
-        <a:font script="Laoo" typeface="DokChampa"/>
-        <a:font script="Sinh" typeface="Iskoola Pota"/>
-        <a:font script="Mong" typeface="Mongolian Baiti"/>
-        <a:font script="Viet" typeface="Times New Roman"/>
-        <a:font script="Uigh" typeface="Microsoft Uighur"/>
-        <a:font script="Geor" typeface="Sylfaen"/>
-        <a:font script="Armn" typeface="Arial"/>
-        <a:font script="Bugi" typeface="Leelawadee UI"/>
-        <a:font script="Bopo" typeface="Microsoft JhengHei"/>
-        <a:font script="Java" typeface="Javanese Text"/>
-        <a:font script="Lisu" typeface="Segoe UI"/>
-        <a:font script="Mymr" typeface="Myanmar Text"/>
-        <a:font script="Nkoo" typeface="Ebrima"/>
-        <a:font script="Olck" typeface="Nirmala UI"/>
-        <a:font script="Osma" typeface="Ebrima"/>
-        <a:font script="Phag" typeface="Phagspa"/>
-        <a:font script="Syrn" typeface="Estrangelo Edessa"/>
-        <a:font script="Syrj" typeface="Estrangelo Edessa"/>
-        <a:font script="Syre" typeface="Estrangelo Edessa"/>
-        <a:font script="Sora" typeface="Nirmala UI"/>
-        <a:font script="Tale" typeface="Microsoft Tai Le"/>
-        <a:font script="Talu" typeface="Microsoft New Tai Lue"/>
-        <a:font script="Tfng" typeface="Ebrima"/>
-      </a:majorFont>
-      <a:minorFont>
-        <a:latin typeface="Aptos" panose="02110004020202020204"/>
-        <a:ea typeface=""/>
-        <a:cs typeface=""/>
-        <a:font script="Jpan" typeface="游ゴシック"/>
-        <a:font script="Hang" typeface="맑은 고딕"/>
-        <a:font script="Hans" typeface="等线"/>
-        <a:font script="Hant" typeface="新細明體"/>
-        <a:font script="Arab" typeface="Arial"/>
-        <a:font script="Hebr" typeface="Arial"/>
-        <a:font script="Thai" typeface="Cordia New"/>
-        <a:font script="Ethi" typeface="Nyala"/>
-        <a:font script="Beng" typeface="Vrinda"/>
-        <a:font script="Gujr" typeface="Shruti"/>
-        <a:font script="Khmr" typeface="DaunPenh"/>
-        <a:font script="Knda" typeface="Tunga"/>
-        <a:font script="Guru" typeface="Raavi"/>
-        <a:font script="Cans" typeface="Euphemia"/>
-        <a:font script="Cher" typeface="Plantagenet Cherokee"/>
-        <a:font script="Yiii" typeface="Microsoft Yi Baiti"/>
-        <a:font script="Tibt" typeface="Microsoft Himalaya"/>
-        <a:font script="Thaa" typeface="MV Boli"/>
-        <a:font script="Deva" typeface="Mangal"/>
-        <a:font script="Telu" typeface="Gautami"/>
-        <a:font script="Taml" typeface="Latha"/>
-        <a:font script="Syrc" typeface="Estrangelo Edessa"/>
-        <a:font script="Orya" typeface="Kalinga"/>
-        <a:font script="Mlym" typeface="Kartika"/>
-        <a:font script="Laoo" typeface="DokChampa"/>
-        <a:font script="Sinh" typeface="Iskoola Pota"/>
-        <a:font script="Mong" typeface="Mongolian Baiti"/>
-        <a:font script="Viet" typeface="Arial"/>
-        <a:font script="Uigh" typeface="Microsoft Uighur"/>
-        <a:font script="Geor" typeface="Sylfaen"/>
-        <a:font script="Armn" typeface="Arial"/>
-        <a:font script="Bugi" typeface="Leelawadee UI"/>
-        <a:font script="Bopo" typeface="Microsoft JhengHei"/>
-        <a:font script="Java" typeface="Javanese Text"/>
-        <a:font script="Lisu" typeface="Segoe UI"/>
-        <a:font script="Mymr" typeface="Myanmar Text"/>
-        <a:font script="Nkoo" typeface="Ebrima"/>
-        <a:font script="Olck" typeface="Nirmala UI"/>
-        <a:font script="Osma" typeface="Ebrima"/>
-        <a:font script="Phag" typeface="Phagspa"/>
-        <a:font script="Syrn" typeface="Estrangelo Edessa"/>
-        <a:font script="Syrj" typeface="Estrangelo Edessa"/>
-        <a:font script="Syre" typeface="Estrangelo Edessa"/>
-        <a:font script="Sora" typeface="Nirmala UI"/>
-        <a:font script="Tale" typeface="Microsoft Tai Le"/>
-        <a:font script="Talu" typeface="Microsoft New Tai Lue"/>
-        <a:font script="Tfng" typeface="Ebrima"/>
-      </a:minorFont>
-    </a:fontScheme>
-    <a:fmtScheme name="Office">
-      <a:fillStyleLst>
-        <a:solidFill>
-          <a:schemeClr val="phClr"/>
-        </a:solidFill>
-        <a:gradFill rotWithShape="1">
-          <a:gsLst>
-            <a:gs pos="0">
-              <a:schemeClr val="phClr">
-                <a:lumMod val="110000"/>
-                <a:satMod val="105000"/>
-                <a:tint val="67000"/>
-              </a:schemeClr>
-            </a:gs>
-            <a:gs pos="50000">
-              <a:schemeClr val="phClr">
-                <a:lumMod val="105000"/>
-                <a:satMod val="103000"/>
-                <a:tint val="73000"/>
-              </a:schemeClr>
-            </a:gs>
-            <a:gs pos="100000">
-              <a:schemeClr val="phClr">
-                <a:lumMod val="105000"/>
-                <a:satMod val="109000"/>
-                <a:tint val="81000"/>
-              </a:schemeClr>
-            </a:gs>
-          </a:gsLst>
-          <a:lin ang="5400000" scaled="0"/>
-        </a:gradFill>
-        <a:gradFill rotWithShape="1">
-          <a:gsLst>
-            <a:gs pos="0">
-              <a:schemeClr val="phClr">
-                <a:satMod val="103000"/>
-                <a:lumMod val="102000"/>
-                <a:tint val="94000"/>
-              </a:schemeClr>
-            </a:gs>
-            <a:gs pos="50000">
-              <a:schemeClr val="phClr">
-                <a:satMod val="110000"/>
-                <a:lumMod val="100000"/>
-                <a:shade val="100000"/>
-              </a:schemeClr>
-            </a:gs>
-            <a:gs pos="100000">
-              <a:schemeClr val="phClr">
-                <a:lumMod val="99000"/>
-                <a:satMod val="120000"/>
-                <a:shade val="78000"/>
-              </a:schemeClr>
-            </a:gs>
-          </a:gsLst>
-          <a:lin ang="5400000" scaled="0"/>
-        </a:gradFill>
-      </a:fillStyleLst>
-      <a:lnStyleLst>
-        <a:ln w="12700" cap="flat" cmpd="sng" algn="ctr">
-          <a:solidFill>
-            <a:schemeClr val="phClr"/>
-          </a:solidFill>
-          <a:prstDash val="solid"/>
-          <a:miter lim="800000"/>
-        </a:ln>
-        <a:ln w="19050" cap="flat" cmpd="sng" algn="ctr">
-          <a:solidFill>
-            <a:schemeClr val="phClr"/>
-          </a:solidFill>
-          <a:prstDash val="solid"/>
-          <a:miter lim="800000"/>
-        </a:ln>
-        <a:ln w="25400" cap="flat" cmpd="sng" algn="ctr">
-          <a:solidFill>
-            <a:schemeClr val="phClr"/>
-          </a:solidFill>
-          <a:prstDash val="solid"/>
-          <a:miter lim="800000"/>
-        </a:ln>
-      </a:lnStyleLst>
-      <a:effectStyleLst>
-        <a:effectStyle>
-          <a:effectLst/>
-        </a:effectStyle>
-        <a:effectStyle>
-          <a:effectLst/>
-        </a:effectStyle>
-        <a:effectStyle>
-          <a:effectLst>
-            <a:outerShdw blurRad="57150" dist="19050" dir="5400000" algn="ctr" rotWithShape="0">
-              <a:srgbClr val="000000">
-                <a:alpha val="63000"/>
-              </a:srgbClr>
-            </a:outerShdw>
-          </a:effectLst>
-        </a:effectStyle>
-      </a:effectStyleLst>
-      <a:bgFillStyleLst>
-        <a:solidFill>
-          <a:schemeClr val="phClr"/>
-        </a:solidFill>
-        <a:solidFill>
-          <a:schemeClr val="phClr">
-            <a:tint val="95000"/>
-            <a:satMod val="170000"/>
-          </a:schemeClr>
-        </a:solidFill>
-        <a:gradFill rotWithShape="1">
-          <a:gsLst>
-            <a:gs pos="0">
-              <a:schemeClr val="phClr">
-                <a:tint val="93000"/>
-                <a:satMod val="150000"/>
-                <a:shade val="98000"/>
-                <a:lumMod val="102000"/>
-              </a:schemeClr>
-            </a:gs>
-            <a:gs pos="50000">
-              <a:schemeClr val="phClr">
-                <a:tint val="98000"/>
-                <a:satMod val="130000"/>
-                <a:shade val="90000"/>
-                <a:lumMod val="103000"/>
-              </a:schemeClr>
-            </a:gs>
-            <a:gs pos="100000">
-              <a:schemeClr val="phClr">
-                <a:shade val="63000"/>
-                <a:satMod val="120000"/>
-              </a:schemeClr>
-            </a:gs>
-          </a:gsLst>
-          <a:lin ang="5400000" scaled="0"/>
-        </a:gradFill>
-      </a:bgFillStyleLst>
-    </a:fmtScheme>
-  </a:themeElements>
-  <a:objectDefaults>
-    <a:lnDef>
-      <a:spPr/>
-      <a:bodyPr/>
-      <a:lstStyle/>
-      <a:style>
-        <a:lnRef idx="2">
-          <a:schemeClr val="accent1"/>
-        </a:lnRef>
-        <a:fillRef idx="0">
-          <a:schemeClr val="accent1"/>
-        </a:fillRef>
-        <a:effectRef idx="1">
-          <a:schemeClr val="accent1"/>
-        </a:effectRef>
-        <a:fontRef idx="minor">
-          <a:schemeClr val="tx1"/>
-        </a:fontRef>
-      </a:style>
-    </a:lnDef>
-  </a:objectDefaults>
-  <a:extraClrSchemeLst/>
-  <a:extLst>
-    <a:ext uri="{05A4C25C-085E-4340-85A3-A5531E510DB2}">
-      <thm15:themeFamily xmlns:thm15="http://schemas.microsoft.com/office/thememl/2012/main" name="Office Theme" id="{2E142A2C-CD16-42D6-873A-C26D2A0506FA}" vid="{1BDDFF52-6CD6-40A5-AB3C-68EB2F1E4D0A}"/>
-    </a:ext>
-  </a:extLst>
-</a:theme>
 </file>
</xml_diff>